<commit_message>
Update: make logo background consistent
</commit_message>
<xml_diff>
--- a/assets/logo.pptx
+++ b/assets/logo.pptx
@@ -105,13 +105,18 @@
       </a:defRPr>
     </a:lvl9pPr>
   </p:defaultTextStyle>
+  <p:extLst>
+    <p:ext uri="{EFAFB233-063F-42B5-8137-9DF3F51BA10A}">
+      <p15:sldGuideLst xmlns:p15="http://schemas.microsoft.com/office/powerpoint/2012/main"/>
+    </p:ext>
+  </p:extLst>
 </p:presentation>
 </file>
 
 <file path=ppt/revisionInfo.xml><?xml version="1.0" encoding="utf-8"?>
 <p1510:revInfo xmlns:a="http://schemas.openxmlformats.org/drawingml/2006/main" xmlns:r="http://schemas.openxmlformats.org/officeDocument/2006/relationships" xmlns:p1510="http://schemas.microsoft.com/office/powerpoint/2015/10/main">
   <p1510:revLst>
-    <p1510:client id="{D4980BA0-0F4A-4214-AB11-EE070FC943DC}" v="44" dt="2023-11-03T05:32:31.404"/>
+    <p1510:client id="{D4980BA0-0F4A-4214-AB11-EE070FC943DC}" v="48" dt="2023-11-05T12:12:39.211"/>
   </p1510:revLst>
 </p1510:revInfo>
 </file>
@@ -121,16 +126,24 @@
   <pc:docChgLst>
     <pc:chgData name="Tim Miller" userId="e118c78a-470c-4863-8b52-3aa598a6a1d5" providerId="ADAL" clId="{D4980BA0-0F4A-4214-AB11-EE070FC943DC}"/>
     <pc:docChg chg="undo custSel addSld modSld">
-      <pc:chgData name="Tim Miller" userId="e118c78a-470c-4863-8b52-3aa598a6a1d5" providerId="ADAL" clId="{D4980BA0-0F4A-4214-AB11-EE070FC943DC}" dt="2023-11-03T05:32:58.030" v="276" actId="478"/>
+      <pc:chgData name="Tim Miller" userId="e118c78a-470c-4863-8b52-3aa598a6a1d5" providerId="ADAL" clId="{D4980BA0-0F4A-4214-AB11-EE070FC943DC}" dt="2023-11-05T12:12:39.211" v="288"/>
       <pc:docMkLst>
         <pc:docMk/>
       </pc:docMkLst>
-      <pc:sldChg chg="addSp delSp modSp new mod">
-        <pc:chgData name="Tim Miller" userId="e118c78a-470c-4863-8b52-3aa598a6a1d5" providerId="ADAL" clId="{D4980BA0-0F4A-4214-AB11-EE070FC943DC}" dt="2023-11-03T05:32:58.030" v="276" actId="478"/>
+      <pc:sldChg chg="addSp delSp modSp new mod setBg">
+        <pc:chgData name="Tim Miller" userId="e118c78a-470c-4863-8b52-3aa598a6a1d5" providerId="ADAL" clId="{D4980BA0-0F4A-4214-AB11-EE070FC943DC}" dt="2023-11-05T12:12:39.211" v="288"/>
         <pc:sldMkLst>
           <pc:docMk/>
           <pc:sldMk cId="3069351669" sldId="256"/>
         </pc:sldMkLst>
+        <pc:spChg chg="add mod ord">
+          <ac:chgData name="Tim Miller" userId="e118c78a-470c-4863-8b52-3aa598a6a1d5" providerId="ADAL" clId="{D4980BA0-0F4A-4214-AB11-EE070FC943DC}" dt="2023-11-05T12:12:29.821" v="287" actId="2085"/>
+          <ac:spMkLst>
+            <pc:docMk/>
+            <pc:sldMk cId="3069351669" sldId="256"/>
+            <ac:spMk id="2" creationId="{D620DB0E-9A1E-2D39-D03C-ED34635C7C00}"/>
+          </ac:spMkLst>
+        </pc:spChg>
         <pc:spChg chg="del">
           <ac:chgData name="Tim Miller" userId="e118c78a-470c-4863-8b52-3aa598a6a1d5" providerId="ADAL" clId="{D4980BA0-0F4A-4214-AB11-EE070FC943DC}" dt="2023-11-03T04:31:58.871" v="5" actId="478"/>
           <ac:spMkLst>
@@ -212,7 +225,7 @@
           </ac:picMkLst>
         </pc:picChg>
         <pc:picChg chg="add mod">
-          <ac:chgData name="Tim Miller" userId="e118c78a-470c-4863-8b52-3aa598a6a1d5" providerId="ADAL" clId="{D4980BA0-0F4A-4214-AB11-EE070FC943DC}" dt="2023-11-03T04:54:51.370" v="199" actId="1076"/>
+          <ac:chgData name="Tim Miller" userId="e118c78a-470c-4863-8b52-3aa598a6a1d5" providerId="ADAL" clId="{D4980BA0-0F4A-4214-AB11-EE070FC943DC}" dt="2023-11-05T12:10:58.541" v="278"/>
           <ac:picMkLst>
             <pc:docMk/>
             <pc:sldMk cId="3069351669" sldId="256"/>
@@ -589,7 +602,7 @@
           <a:p>
             <a:fld id="{FADD0E76-BE76-42D7-866C-286855711181}" type="datetimeFigureOut">
               <a:rPr lang="en-AU" smtClean="0"/>
-              <a:t>3/11/2023</a:t>
+              <a:t>5/11/2023</a:t>
             </a:fld>
             <a:endParaRPr lang="en-AU"/>
           </a:p>
@@ -789,7 +802,7 @@
           <a:p>
             <a:fld id="{FADD0E76-BE76-42D7-866C-286855711181}" type="datetimeFigureOut">
               <a:rPr lang="en-AU" smtClean="0"/>
-              <a:t>3/11/2023</a:t>
+              <a:t>5/11/2023</a:t>
             </a:fld>
             <a:endParaRPr lang="en-AU"/>
           </a:p>
@@ -999,7 +1012,7 @@
           <a:p>
             <a:fld id="{FADD0E76-BE76-42D7-866C-286855711181}" type="datetimeFigureOut">
               <a:rPr lang="en-AU" smtClean="0"/>
-              <a:t>3/11/2023</a:t>
+              <a:t>5/11/2023</a:t>
             </a:fld>
             <a:endParaRPr lang="en-AU"/>
           </a:p>
@@ -1199,7 +1212,7 @@
           <a:p>
             <a:fld id="{FADD0E76-BE76-42D7-866C-286855711181}" type="datetimeFigureOut">
               <a:rPr lang="en-AU" smtClean="0"/>
-              <a:t>3/11/2023</a:t>
+              <a:t>5/11/2023</a:t>
             </a:fld>
             <a:endParaRPr lang="en-AU"/>
           </a:p>
@@ -1475,7 +1488,7 @@
           <a:p>
             <a:fld id="{FADD0E76-BE76-42D7-866C-286855711181}" type="datetimeFigureOut">
               <a:rPr lang="en-AU" smtClean="0"/>
-              <a:t>3/11/2023</a:t>
+              <a:t>5/11/2023</a:t>
             </a:fld>
             <a:endParaRPr lang="en-AU"/>
           </a:p>
@@ -1743,7 +1756,7 @@
           <a:p>
             <a:fld id="{FADD0E76-BE76-42D7-866C-286855711181}" type="datetimeFigureOut">
               <a:rPr lang="en-AU" smtClean="0"/>
-              <a:t>3/11/2023</a:t>
+              <a:t>5/11/2023</a:t>
             </a:fld>
             <a:endParaRPr lang="en-AU"/>
           </a:p>
@@ -2158,7 +2171,7 @@
           <a:p>
             <a:fld id="{FADD0E76-BE76-42D7-866C-286855711181}" type="datetimeFigureOut">
               <a:rPr lang="en-AU" smtClean="0"/>
-              <a:t>3/11/2023</a:t>
+              <a:t>5/11/2023</a:t>
             </a:fld>
             <a:endParaRPr lang="en-AU"/>
           </a:p>
@@ -2300,7 +2313,7 @@
           <a:p>
             <a:fld id="{FADD0E76-BE76-42D7-866C-286855711181}" type="datetimeFigureOut">
               <a:rPr lang="en-AU" smtClean="0"/>
-              <a:t>3/11/2023</a:t>
+              <a:t>5/11/2023</a:t>
             </a:fld>
             <a:endParaRPr lang="en-AU"/>
           </a:p>
@@ -2413,7 +2426,7 @@
           <a:p>
             <a:fld id="{FADD0E76-BE76-42D7-866C-286855711181}" type="datetimeFigureOut">
               <a:rPr lang="en-AU" smtClean="0"/>
-              <a:t>3/11/2023</a:t>
+              <a:t>5/11/2023</a:t>
             </a:fld>
             <a:endParaRPr lang="en-AU"/>
           </a:p>
@@ -2726,7 +2739,7 @@
           <a:p>
             <a:fld id="{FADD0E76-BE76-42D7-866C-286855711181}" type="datetimeFigureOut">
               <a:rPr lang="en-AU" smtClean="0"/>
-              <a:t>3/11/2023</a:t>
+              <a:t>5/11/2023</a:t>
             </a:fld>
             <a:endParaRPr lang="en-AU"/>
           </a:p>
@@ -3015,7 +3028,7 @@
           <a:p>
             <a:fld id="{FADD0E76-BE76-42D7-866C-286855711181}" type="datetimeFigureOut">
               <a:rPr lang="en-AU" smtClean="0"/>
-              <a:t>3/11/2023</a:t>
+              <a:t>5/11/2023</a:t>
             </a:fld>
             <a:endParaRPr lang="en-AU"/>
           </a:p>
@@ -3258,7 +3271,7 @@
           <a:p>
             <a:fld id="{FADD0E76-BE76-42D7-866C-286855711181}" type="datetimeFigureOut">
               <a:rPr lang="en-AU" smtClean="0"/>
-              <a:t>3/11/2023</a:t>
+              <a:t>5/11/2023</a:t>
             </a:fld>
             <a:endParaRPr lang="en-AU"/>
           </a:p>
@@ -3661,6 +3674,14 @@
 <file path=ppt/slides/slide1.xml><?xml version="1.0" encoding="utf-8"?>
 <p:sld xmlns:a="http://schemas.openxmlformats.org/drawingml/2006/main" xmlns:r="http://schemas.openxmlformats.org/officeDocument/2006/relationships" xmlns:p="http://schemas.openxmlformats.org/presentationml/2006/main">
   <p:cSld>
+    <p:bg>
+      <p:bgPr>
+        <a:solidFill>
+          <a:schemeClr val="bg1"/>
+        </a:solidFill>
+        <a:effectLst/>
+      </p:bgPr>
+    </p:bg>
     <p:spTree>
       <p:nvGrpSpPr>
         <p:cNvPr id="1" name=""/>
@@ -3675,6 +3696,58 @@
           <a:chExt cx="0" cy="0"/>
         </a:xfrm>
       </p:grpSpPr>
+      <p:sp>
+        <p:nvSpPr>
+          <p:cNvPr id="2" name="Rectangle 1">
+            <a:extLst>
+              <a:ext uri="{FF2B5EF4-FFF2-40B4-BE49-F238E27FC236}">
+                <a16:creationId xmlns:a16="http://schemas.microsoft.com/office/drawing/2014/main" id="{D620DB0E-9A1E-2D39-D03C-ED34635C7C00}"/>
+              </a:ext>
+            </a:extLst>
+          </p:cNvPr>
+          <p:cNvSpPr/>
+          <p:nvPr/>
+        </p:nvSpPr>
+        <p:spPr>
+          <a:xfrm>
+            <a:off x="2692853" y="1952625"/>
+            <a:ext cx="4203247" cy="3252788"/>
+          </a:xfrm>
+          <a:prstGeom prst="rect">
+            <a:avLst/>
+          </a:prstGeom>
+          <a:solidFill>
+            <a:schemeClr val="bg1"/>
+          </a:solidFill>
+          <a:ln>
+            <a:noFill/>
+          </a:ln>
+        </p:spPr>
+        <p:style>
+          <a:lnRef idx="2">
+            <a:schemeClr val="accent1">
+              <a:shade val="15000"/>
+            </a:schemeClr>
+          </a:lnRef>
+          <a:fillRef idx="1">
+            <a:schemeClr val="accent1"/>
+          </a:fillRef>
+          <a:effectRef idx="0">
+            <a:schemeClr val="accent1"/>
+          </a:effectRef>
+          <a:fontRef idx="minor">
+            <a:schemeClr val="lt1"/>
+          </a:fontRef>
+        </p:style>
+        <p:txBody>
+          <a:bodyPr rtlCol="0" anchor="ctr"/>
+          <a:lstStyle/>
+          <a:p>
+            <a:pPr algn="ctr"/>
+            <a:endParaRPr lang="en-AU"/>
+          </a:p>
+        </p:txBody>
+      </p:sp>
       <p:pic>
         <p:nvPicPr>
           <p:cNvPr id="1058" name="Picture 1057" descr="A diagram of a circuit&#10;&#10;Description automatically generated">

</xml_diff>

<commit_message>
ADD: Multi-armed bandit figure.
</commit_message>
<xml_diff>
--- a/assets/logo.pptx
+++ b/assets/logo.pptx
@@ -126,12 +126,12 @@
   <pc:docChgLst>
     <pc:chgData name="Tim Miller" userId="e118c78a-470c-4863-8b52-3aa598a6a1d5" providerId="ADAL" clId="{D4980BA0-0F4A-4214-AB11-EE070FC943DC}"/>
     <pc:docChg chg="undo custSel addSld modSld">
-      <pc:chgData name="Tim Miller" userId="e118c78a-470c-4863-8b52-3aa598a6a1d5" providerId="ADAL" clId="{D4980BA0-0F4A-4214-AB11-EE070FC943DC}" dt="2023-11-05T12:12:39.211" v="288"/>
+      <pc:chgData name="Tim Miller" userId="e118c78a-470c-4863-8b52-3aa598a6a1d5" providerId="ADAL" clId="{D4980BA0-0F4A-4214-AB11-EE070FC943DC}" dt="2023-11-10T21:37:11.813" v="292" actId="1076"/>
       <pc:docMkLst>
         <pc:docMk/>
       </pc:docMkLst>
       <pc:sldChg chg="addSp delSp modSp new mod setBg">
-        <pc:chgData name="Tim Miller" userId="e118c78a-470c-4863-8b52-3aa598a6a1d5" providerId="ADAL" clId="{D4980BA0-0F4A-4214-AB11-EE070FC943DC}" dt="2023-11-05T12:12:39.211" v="288"/>
+        <pc:chgData name="Tim Miller" userId="e118c78a-470c-4863-8b52-3aa598a6a1d5" providerId="ADAL" clId="{D4980BA0-0F4A-4214-AB11-EE070FC943DC}" dt="2023-11-10T21:37:11.813" v="292" actId="1076"/>
         <pc:sldMkLst>
           <pc:docMk/>
           <pc:sldMk cId="3069351669" sldId="256"/>
@@ -225,7 +225,7 @@
           </ac:picMkLst>
         </pc:picChg>
         <pc:picChg chg="add mod">
-          <ac:chgData name="Tim Miller" userId="e118c78a-470c-4863-8b52-3aa598a6a1d5" providerId="ADAL" clId="{D4980BA0-0F4A-4214-AB11-EE070FC943DC}" dt="2023-11-05T12:10:58.541" v="278"/>
+          <ac:chgData name="Tim Miller" userId="e118c78a-470c-4863-8b52-3aa598a6a1d5" providerId="ADAL" clId="{D4980BA0-0F4A-4214-AB11-EE070FC943DC}" dt="2023-11-10T21:37:11.813" v="292" actId="1076"/>
           <ac:picMkLst>
             <pc:docMk/>
             <pc:sldMk cId="3069351669" sldId="256"/>
@@ -602,7 +602,7 @@
           <a:p>
             <a:fld id="{FADD0E76-BE76-42D7-866C-286855711181}" type="datetimeFigureOut">
               <a:rPr lang="en-AU" smtClean="0"/>
-              <a:t>5/11/2023</a:t>
+              <a:t>11/11/2023</a:t>
             </a:fld>
             <a:endParaRPr lang="en-AU"/>
           </a:p>
@@ -802,7 +802,7 @@
           <a:p>
             <a:fld id="{FADD0E76-BE76-42D7-866C-286855711181}" type="datetimeFigureOut">
               <a:rPr lang="en-AU" smtClean="0"/>
-              <a:t>5/11/2023</a:t>
+              <a:t>11/11/2023</a:t>
             </a:fld>
             <a:endParaRPr lang="en-AU"/>
           </a:p>
@@ -1012,7 +1012,7 @@
           <a:p>
             <a:fld id="{FADD0E76-BE76-42D7-866C-286855711181}" type="datetimeFigureOut">
               <a:rPr lang="en-AU" smtClean="0"/>
-              <a:t>5/11/2023</a:t>
+              <a:t>11/11/2023</a:t>
             </a:fld>
             <a:endParaRPr lang="en-AU"/>
           </a:p>
@@ -1212,7 +1212,7 @@
           <a:p>
             <a:fld id="{FADD0E76-BE76-42D7-866C-286855711181}" type="datetimeFigureOut">
               <a:rPr lang="en-AU" smtClean="0"/>
-              <a:t>5/11/2023</a:t>
+              <a:t>11/11/2023</a:t>
             </a:fld>
             <a:endParaRPr lang="en-AU"/>
           </a:p>
@@ -1488,7 +1488,7 @@
           <a:p>
             <a:fld id="{FADD0E76-BE76-42D7-866C-286855711181}" type="datetimeFigureOut">
               <a:rPr lang="en-AU" smtClean="0"/>
-              <a:t>5/11/2023</a:t>
+              <a:t>11/11/2023</a:t>
             </a:fld>
             <a:endParaRPr lang="en-AU"/>
           </a:p>
@@ -1756,7 +1756,7 @@
           <a:p>
             <a:fld id="{FADD0E76-BE76-42D7-866C-286855711181}" type="datetimeFigureOut">
               <a:rPr lang="en-AU" smtClean="0"/>
-              <a:t>5/11/2023</a:t>
+              <a:t>11/11/2023</a:t>
             </a:fld>
             <a:endParaRPr lang="en-AU"/>
           </a:p>
@@ -2171,7 +2171,7 @@
           <a:p>
             <a:fld id="{FADD0E76-BE76-42D7-866C-286855711181}" type="datetimeFigureOut">
               <a:rPr lang="en-AU" smtClean="0"/>
-              <a:t>5/11/2023</a:t>
+              <a:t>11/11/2023</a:t>
             </a:fld>
             <a:endParaRPr lang="en-AU"/>
           </a:p>
@@ -2313,7 +2313,7 @@
           <a:p>
             <a:fld id="{FADD0E76-BE76-42D7-866C-286855711181}" type="datetimeFigureOut">
               <a:rPr lang="en-AU" smtClean="0"/>
-              <a:t>5/11/2023</a:t>
+              <a:t>11/11/2023</a:t>
             </a:fld>
             <a:endParaRPr lang="en-AU"/>
           </a:p>
@@ -2426,7 +2426,7 @@
           <a:p>
             <a:fld id="{FADD0E76-BE76-42D7-866C-286855711181}" type="datetimeFigureOut">
               <a:rPr lang="en-AU" smtClean="0"/>
-              <a:t>5/11/2023</a:t>
+              <a:t>11/11/2023</a:t>
             </a:fld>
             <a:endParaRPr lang="en-AU"/>
           </a:p>
@@ -2739,7 +2739,7 @@
           <a:p>
             <a:fld id="{FADD0E76-BE76-42D7-866C-286855711181}" type="datetimeFigureOut">
               <a:rPr lang="en-AU" smtClean="0"/>
-              <a:t>5/11/2023</a:t>
+              <a:t>11/11/2023</a:t>
             </a:fld>
             <a:endParaRPr lang="en-AU"/>
           </a:p>
@@ -3028,7 +3028,7 @@
           <a:p>
             <a:fld id="{FADD0E76-BE76-42D7-866C-286855711181}" type="datetimeFigureOut">
               <a:rPr lang="en-AU" smtClean="0"/>
-              <a:t>5/11/2023</a:t>
+              <a:t>11/11/2023</a:t>
             </a:fld>
             <a:endParaRPr lang="en-AU"/>
           </a:p>
@@ -3271,7 +3271,7 @@
           <a:p>
             <a:fld id="{FADD0E76-BE76-42D7-866C-286855711181}" type="datetimeFigureOut">
               <a:rPr lang="en-AU" smtClean="0"/>
-              <a:t>5/11/2023</a:t>
+              <a:t>11/11/2023</a:t>
             </a:fld>
             <a:endParaRPr lang="en-AU"/>
           </a:p>
@@ -3776,7 +3776,7 @@
         </p:blipFill>
         <p:spPr>
           <a:xfrm>
-            <a:off x="2692853" y="1990079"/>
+            <a:off x="2705100" y="2000250"/>
             <a:ext cx="4191000" cy="2857500"/>
           </a:xfrm>
           <a:prstGeom prst="rect">

</xml_diff>